<commit_message>
sync: regenerate derived figures from the merged binary (train 23 rebase)
Re-capture the showcase against 2026-10-03's merged tree (new whereis/
edit-check help lines moved the legend dict), regenerate docs/COMMANDS.md
(181 flags), the deck pptx/pdf, and restate the paging entry's tools/list
figure honestly: 46,581 -> 46,765 B measured live on both trees, ceiling
46,700 -> 46,800. help_all re-pinned for the new --help lines.
</commit_message>
<xml_diff>
--- a/present/ripwire-showcase.pptx
+++ b/present/ripwire-showcase.pptx
@@ -26038,7 +26038,7 @@
                 <a:ea typeface="Arial" pitchFamily="34" charset="-122"/>
                 <a:cs typeface="Arial" pitchFamily="34" charset="-120"/>
               </a:rPr>
-              <a:t>658 gate scripts</a:t>
+              <a:t>660 gate scripts</a:t>
             </a:r>
             <a:endParaRPr lang="en-US" sz="1450" dirty="0"/>
           </a:p>
@@ -26778,7 +26778,7 @@
                 <a:ea typeface="Arial" pitchFamily="34" charset="-122"/>
                 <a:cs typeface="Arial" pitchFamily="34" charset="-120"/>
               </a:rPr>
-              <a:t>658</a:t>
+              <a:t>660</a:t>
             </a:r>
             <a:endParaRPr lang="en-US" sz="4200" dirty="0"/>
           </a:p>
@@ -35203,7 +35203,7 @@
                 <a:ea typeface="Arial" pitchFamily="34" charset="-122"/>
                 <a:cs typeface="Arial" pitchFamily="34" charset="-120"/>
               </a:rPr>
-              <a:t>658 gate scripts</a:t>
+              <a:t>660 gate scripts</a:t>
             </a:r>
             <a:endParaRPr lang="en-US" sz="1200" dirty="0"/>
           </a:p>

</xml_diff>

<commit_message>
sync: regenerate derived figures from the merged binary (train 25 rebase)
Re-capture the showcase against 2026-10-07's merged tree, regenerate
docs/COMMANDS.md, the deck pptx/pdf, and restate both [Unreleased]
tools/list figures to the live merged-tree measurement: the paging
schema takes it 46,732 -> 46,916 B, ceiling 46,750 -> 46,950 (the
valueRefs entry re-pinned to the same live figure, per the gate's
mutable-[Unreleased] contract). help_all and four more pins re-pinned
for the train-25 help lines.
</commit_message>
<xml_diff>
--- a/present/ripwire-showcase.pptx
+++ b/present/ripwire-showcase.pptx
@@ -26038,7 +26038,7 @@
                 <a:ea typeface="Arial" pitchFamily="34" charset="-122"/>
                 <a:cs typeface="Arial" pitchFamily="34" charset="-120"/>
               </a:rPr>
-              <a:t>660 gate scripts</a:t>
+              <a:t>664 gate scripts</a:t>
             </a:r>
             <a:endParaRPr lang="en-US" sz="1450" dirty="0"/>
           </a:p>
@@ -26778,7 +26778,7 @@
                 <a:ea typeface="Arial" pitchFamily="34" charset="-122"/>
                 <a:cs typeface="Arial" pitchFamily="34" charset="-120"/>
               </a:rPr>
-              <a:t>660</a:t>
+              <a:t>664</a:t>
             </a:r>
             <a:endParaRPr lang="en-US" sz="4200" dirty="0"/>
           </a:p>
@@ -35203,7 +35203,7 @@
                 <a:ea typeface="Arial" pitchFamily="34" charset="-122"/>
                 <a:cs typeface="Arial" pitchFamily="34" charset="-120"/>
               </a:rPr>
-              <a:t>660 gate scripts</a:t>
+              <a:t>664 gate scripts</a:t>
             </a:r>
             <a:endParaRPr lang="en-US" sz="1200" dirty="0"/>
           </a:p>

</xml_diff>